<commit_message>
Emphasize Orbit Engine architecture value
</commit_message>
<xml_diff>
--- a/ppt/orbit_engine_value_proposal_v3.pptx
+++ b/ppt/orbit_engine_value_proposal_v3.pptx
@@ -24680,17 +24680,16 @@
           </a:bodyPr>
           <a:lstStyle/>
           <a:p>
-            <a:pPr algn="l"/>
-            <a:r>
-              <a:rPr sz="1000" b="1">
-                <a:ea typeface="Noto Sans CJK SC"/>
-                <a:cs typeface="Noto Sans CJK SC"/>
-                <a:solidFill>
-                  <a:srgbClr val="225BB7"/>
-                </a:solidFill>
-                <a:latin typeface="Noto Sans CJK SC"/>
-              </a:rPr>
-              <a:t>08 · ARCHITECTURE &amp; TECH STACK</a:t>
+            <a:pPr>
+              <a:defRPr sz="1200">
+                <a:solidFill>
+                  <a:srgbClr val="4B8FFF"/>
+                </a:solidFill>
+                <a:latin typeface="Aptos"/>
+              </a:defRPr>
+            </a:pPr>
+            <a:r>
+              <a:t>08 · ARCHITECTURE ADVANTAGE</a:t>
             </a:r>
           </a:p>
         </p:txBody>
@@ -24752,17 +24751,16 @@
           </a:bodyPr>
           <a:lstStyle/>
           <a:p>
-            <a:pPr algn="l"/>
-            <a:r>
-              <a:rPr sz="2800" b="1">
-                <a:ea typeface="Noto Sans CJK SC"/>
-                <a:cs typeface="Noto Sans CJK SC"/>
-                <a:solidFill>
-                  <a:srgbClr val="1C202C"/>
-                </a:solidFill>
-                <a:latin typeface="Noto Sans CJK SC"/>
-              </a:rPr>
-              <a:t>可替换、可复用的 Agent 应用架构</a:t>
+            <a:pPr>
+              <a:defRPr sz="2800">
+                <a:solidFill>
+                  <a:srgbClr val="1F2333"/>
+                </a:solidFill>
+                <a:latin typeface="Aptos"/>
+              </a:defRPr>
+            </a:pPr>
+            <a:r>
+              <a:t>把专业成长做成可循环的行动基础设施</a:t>
             </a:r>
           </a:p>
         </p:txBody>
@@ -24789,17 +24787,16 @@
           </a:bodyPr>
           <a:lstStyle/>
           <a:p>
-            <a:pPr algn="l"/>
-            <a:r>
-              <a:rPr sz="1300" b="0">
-                <a:ea typeface="Noto Sans CJK SC"/>
-                <a:cs typeface="Noto Sans CJK SC"/>
-                <a:solidFill>
-                  <a:srgbClr val="5E6574"/>
-                </a:solidFill>
-                <a:latin typeface="Noto Sans CJK SC"/>
-              </a:rPr>
-              <a:t>前端只消费结构化 JSON;后端负责节奏、材料、会话、打卡和历史。</a:t>
+            <a:pPr>
+              <a:defRPr sz="1500">
+                <a:solidFill>
+                  <a:srgbClr val="5B6279"/>
+                </a:solidFill>
+                <a:latin typeface="Aptos"/>
+              </a:defRPr>
+            </a:pPr>
+            <a:r>
+              <a:t>稳定的是闭环；可替换的是模型、材料源与领域配置。</a:t>
             </a:r>
           </a:p>
         </p:txBody>
@@ -24991,17 +24988,16 @@
           </a:bodyPr>
           <a:lstStyle/>
           <a:p>
-            <a:pPr algn="l"/>
-            <a:r>
-              <a:rPr sz="1300" b="1">
-                <a:ea typeface="Noto Sans CJK SC"/>
-                <a:cs typeface="Noto Sans CJK SC"/>
-                <a:solidFill>
-                  <a:srgbClr val="225BB7"/>
-                </a:solidFill>
-                <a:latin typeface="Noto Sans CJK SC"/>
-              </a:rPr>
-              <a:t>Interface</a:t>
+            <a:pPr>
+              <a:defRPr sz="1500">
+                <a:solidFill>
+                  <a:srgbClr val="1F2333"/>
+                </a:solidFill>
+                <a:latin typeface="Aptos"/>
+              </a:defRPr>
+            </a:pPr>
+            <a:r>
+              <a:t>一致入口</a:t>
             </a:r>
           </a:p>
         </p:txBody>
@@ -25029,56 +25025,77 @@
           <a:lstStyle/>
           <a:p>
             <a:pPr>
-              <a:lnSpc>
-                <a:spcPct val="135000"/>
-              </a:lnSpc>
+              <a:defRPr sz="1400">
+                <a:solidFill>
+                  <a:srgbClr val="1F2333"/>
+                </a:solidFill>
+                <a:latin typeface="Aptos"/>
+              </a:defRPr>
             </a:pPr>
             <a:r>
-              <a:rPr sz="950" b="0">
-                <a:ea typeface="Noto Sans CJK SC"/>
-                <a:cs typeface="Noto Sans CJK SC"/>
-                <a:solidFill>
-                  <a:srgbClr val="1C202C"/>
-                </a:solidFill>
-                <a:latin typeface="Noto Sans CJK SC"/>
-              </a:rPr>
-              <a:t>Mobile SwiftUI iOS</a:t>
+              <a:t>SwiftUI iOS 主端</a:t>
             </a:r>
           </a:p>
           <a:p>
             <a:pPr>
-              <a:lnSpc>
-                <a:spcPct val="135000"/>
-              </a:lnSpc>
+              <a:defRPr sz="1400">
+                <a:solidFill>
+                  <a:srgbClr val="1F2333"/>
+                </a:solidFill>
+                <a:latin typeface="Aptos"/>
+              </a:defRPr>
             </a:pPr>
             <a:r>
-              <a:rPr sz="950" b="0">
-                <a:ea typeface="Noto Sans CJK SC"/>
-                <a:cs typeface="Noto Sans CJK SC"/>
-                <a:solidFill>
-                  <a:srgbClr val="1C202C"/>
-                </a:solidFill>
-                <a:latin typeface="Noto Sans CJK SC"/>
-              </a:rPr>
-              <a:t>Mobile Web (fallback)</a:t>
+              <a:t>Web 作为 fallback</a:t>
             </a:r>
           </a:p>
           <a:p>
             <a:pPr>
-              <a:lnSpc>
-                <a:spcPct val="135000"/>
-              </a:lnSpc>
+              <a:defRPr sz="1400">
+                <a:solidFill>
+                  <a:srgbClr val="1F2333"/>
+                </a:solidFill>
+                <a:latin typeface="Aptos"/>
+              </a:defRPr>
             </a:pPr>
             <a:r>
-              <a:rPr sz="950" b="0">
-                <a:ea typeface="Noto Sans CJK SC"/>
-                <a:cs typeface="Noto Sans CJK SC"/>
-                <a:solidFill>
-                  <a:srgbClr val="1C202C"/>
-                </a:solidFill>
-                <a:latin typeface="Noto Sans CJK SC"/>
-              </a:rPr>
               <a:t>Today / History / Plan / My</a:t>
+            </a:r>
+          </a:p>
+          <a:p>
+            <a:pPr>
+              <a:defRPr sz="1400">
+                <a:solidFill>
+                  <a:srgbClr val="1F2333"/>
+                </a:solidFill>
+                <a:latin typeface="Aptos"/>
+              </a:defRPr>
+            </a:pPr>
+          </a:p>
+          <a:p>
+            <a:pPr>
+              <a:defRPr sz="1400">
+                <a:solidFill>
+                  <a:srgbClr val="1F2333"/>
+                </a:solidFill>
+                <a:latin typeface="Aptos"/>
+              </a:defRPr>
+            </a:pPr>
+            <a:r>
+              <a:t>价值：用户每天从同一入口</a:t>
+            </a:r>
+          </a:p>
+          <a:p>
+            <a:pPr>
+              <a:defRPr sz="1400">
+                <a:solidFill>
+                  <a:srgbClr val="1F2333"/>
+                </a:solidFill>
+                <a:latin typeface="Aptos"/>
+              </a:defRPr>
+            </a:pPr>
+            <a:r>
+              <a:t>进入明确的下一步</a:t>
             </a:r>
           </a:p>
         </p:txBody>
@@ -25196,17 +25213,16 @@
           </a:bodyPr>
           <a:lstStyle/>
           <a:p>
-            <a:pPr algn="l"/>
-            <a:r>
-              <a:rPr sz="1300" b="1">
-                <a:ea typeface="Noto Sans CJK SC"/>
-                <a:cs typeface="Noto Sans CJK SC"/>
-                <a:solidFill>
-                  <a:srgbClr val="0F8DA6"/>
-                </a:solidFill>
-                <a:latin typeface="Noto Sans CJK SC"/>
-              </a:rPr>
-              <a:t>Session Runtime</a:t>
+            <a:pPr>
+              <a:defRPr sz="1500">
+                <a:solidFill>
+                  <a:srgbClr val="1F2333"/>
+                </a:solidFill>
+                <a:latin typeface="Aptos"/>
+              </a:defRPr>
+            </a:pPr>
+            <a:r>
+              <a:t>稳定闭环</a:t>
             </a:r>
           </a:p>
         </p:txBody>
@@ -25234,56 +25250,77 @@
           <a:lstStyle/>
           <a:p>
             <a:pPr>
-              <a:lnSpc>
-                <a:spcPct val="135000"/>
-              </a:lnSpc>
+              <a:defRPr sz="1400">
+                <a:solidFill>
+                  <a:srgbClr val="1F2333"/>
+                </a:solidFill>
+                <a:latin typeface="Aptos"/>
+              </a:defRPr>
             </a:pPr>
             <a:r>
-              <a:rPr sz="950" b="0">
-                <a:ea typeface="Noto Sans CJK SC"/>
-                <a:cs typeface="Noto Sans CJK SC"/>
-                <a:solidFill>
-                  <a:srgbClr val="1C202C"/>
-                </a:solidFill>
-                <a:latin typeface="Noto Sans CJK SC"/>
-              </a:rPr>
               <a:t>Weekly Coordinator</a:t>
             </a:r>
           </a:p>
           <a:p>
             <a:pPr>
-              <a:lnSpc>
-                <a:spcPct val="135000"/>
-              </a:lnSpc>
+              <a:defRPr sz="1400">
+                <a:solidFill>
+                  <a:srgbClr val="1F2333"/>
+                </a:solidFill>
+                <a:latin typeface="Aptos"/>
+              </a:defRPr>
             </a:pPr>
             <a:r>
-              <a:rPr sz="950" b="0">
-                <a:ea typeface="Noto Sans CJK SC"/>
-                <a:cs typeface="Noto Sans CJK SC"/>
-                <a:solidFill>
-                  <a:srgbClr val="1C202C"/>
-                </a:solidFill>
-                <a:latin typeface="Noto Sans CJK SC"/>
-              </a:rPr>
-              <a:t>BaseSession (Radar / Dive / Opp / Studio)</a:t>
+              <a:t>BaseSession 四类模板</a:t>
             </a:r>
           </a:p>
           <a:p>
             <a:pPr>
-              <a:lnSpc>
-                <a:spcPct val="135000"/>
-              </a:lnSpc>
+              <a:defRPr sz="1400">
+                <a:solidFill>
+                  <a:srgbClr val="1F2333"/>
+                </a:solidFill>
+                <a:latin typeface="Aptos"/>
+              </a:defRPr>
             </a:pPr>
             <a:r>
-              <a:rPr sz="950" b="0">
-                <a:ea typeface="Noto Sans CJK SC"/>
-                <a:cs typeface="Noto Sans CJK SC"/>
-                <a:solidFill>
-                  <a:srgbClr val="1C202C"/>
-                </a:solidFill>
-                <a:latin typeface="Noto Sans CJK SC"/>
-              </a:rPr>
               <a:t>Session queue + completion</a:t>
+            </a:r>
+          </a:p>
+          <a:p>
+            <a:pPr>
+              <a:defRPr sz="1400">
+                <a:solidFill>
+                  <a:srgbClr val="1F2333"/>
+                </a:solidFill>
+                <a:latin typeface="Aptos"/>
+              </a:defRPr>
+            </a:pPr>
+          </a:p>
+          <a:p>
+            <a:pPr>
+              <a:defRPr sz="1400">
+                <a:solidFill>
+                  <a:srgbClr val="1F2333"/>
+                </a:solidFill>
+                <a:latin typeface="Aptos"/>
+              </a:defRPr>
+            </a:pPr>
+            <a:r>
+              <a:t>价值：任务有状态、可暂停、</a:t>
+            </a:r>
+          </a:p>
+          <a:p>
+            <a:pPr>
+              <a:defRPr sz="1400">
+                <a:solidFill>
+                  <a:srgbClr val="1F2333"/>
+                </a:solidFill>
+                <a:latin typeface="Aptos"/>
+              </a:defRPr>
+            </a:pPr>
+            <a:r>
+              <a:t>可确认、可进入下一轮</a:t>
             </a:r>
           </a:p>
         </p:txBody>
@@ -25401,17 +25438,16 @@
           </a:bodyPr>
           <a:lstStyle/>
           <a:p>
-            <a:pPr algn="l"/>
-            <a:r>
-              <a:rPr sz="1300" b="1">
-                <a:ea typeface="Noto Sans CJK SC"/>
-                <a:cs typeface="Noto Sans CJK SC"/>
-                <a:solidFill>
-                  <a:srgbClr val="E07A2E"/>
-                </a:solidFill>
-                <a:latin typeface="Noto Sans CJK SC"/>
-              </a:rPr>
-              <a:t>Agent Skills</a:t>
+            <a:pPr>
+              <a:defRPr sz="1500">
+                <a:solidFill>
+                  <a:srgbClr val="1F2333"/>
+                </a:solidFill>
+                <a:latin typeface="Aptos"/>
+              </a:defRPr>
+            </a:pPr>
+            <a:r>
+              <a:t>任务型 Agent</a:t>
             </a:r>
           </a:p>
         </p:txBody>
@@ -25439,74 +25475,90 @@
           <a:lstStyle/>
           <a:p>
             <a:pPr>
-              <a:lnSpc>
-                <a:spcPct val="135000"/>
-              </a:lnSpc>
+              <a:defRPr sz="1400">
+                <a:solidFill>
+                  <a:srgbClr val="1F2333"/>
+                </a:solidFill>
+                <a:latin typeface="Aptos"/>
+              </a:defRPr>
             </a:pPr>
             <a:r>
-              <a:rPr sz="950" b="0">
-                <a:ea typeface="Noto Sans CJK SC"/>
-                <a:cs typeface="Noto Sans CJK SC"/>
-                <a:solidFill>
-                  <a:srgbClr val="1C202C"/>
-                </a:solidFill>
-                <a:latin typeface="Noto Sans CJK SC"/>
-              </a:rPr>
-              <a:t>Research Feeder(公开源)</a:t>
+              <a:t>Research Feeder</a:t>
             </a:r>
           </a:p>
           <a:p>
             <a:pPr>
-              <a:lnSpc>
-                <a:spcPct val="135000"/>
-              </a:lnSpc>
+              <a:defRPr sz="1400">
+                <a:solidFill>
+                  <a:srgbClr val="1F2333"/>
+                </a:solidFill>
+                <a:latin typeface="Aptos"/>
+              </a:defRPr>
             </a:pPr>
             <a:r>
-              <a:rPr sz="950" b="0">
-                <a:ea typeface="Noto Sans CJK SC"/>
-                <a:cs typeface="Noto Sans CJK SC"/>
-                <a:solidFill>
-                  <a:srgbClr val="1C202C"/>
-                </a:solidFill>
-                <a:latin typeface="Noto Sans CJK SC"/>
-              </a:rPr>
-              <a:t>Tech Radar(RSS + 网页 + dedup)</a:t>
+              <a:t>Tech Radar</a:t>
             </a:r>
           </a:p>
           <a:p>
             <a:pPr>
-              <a:lnSpc>
-                <a:spcPct val="135000"/>
-              </a:lnSpc>
+              <a:defRPr sz="1400">
+                <a:solidFill>
+                  <a:srgbClr val="1F2333"/>
+                </a:solidFill>
+                <a:latin typeface="Aptos"/>
+              </a:defRPr>
             </a:pPr>
             <a:r>
-              <a:rPr sz="950" b="0">
-                <a:ea typeface="Noto Sans CJK SC"/>
-                <a:cs typeface="Noto Sans CJK SC"/>
-                <a:solidFill>
-                  <a:srgbClr val="1C202C"/>
-                </a:solidFill>
-                <a:latin typeface="Noto Sans CJK SC"/>
-              </a:rPr>
-              <a:t>JD / Opportunity Agent</a:t>
+              <a:t>Opportunity Alignment</a:t>
             </a:r>
           </a:p>
           <a:p>
             <a:pPr>
-              <a:lnSpc>
-                <a:spcPct val="135000"/>
-              </a:lnSpc>
+              <a:defRPr sz="1400">
+                <a:solidFill>
+                  <a:srgbClr val="1F2333"/>
+                </a:solidFill>
+                <a:latin typeface="Aptos"/>
+              </a:defRPr>
             </a:pPr>
             <a:r>
-              <a:rPr sz="950" b="0">
-                <a:ea typeface="Noto Sans CJK SC"/>
-                <a:cs typeface="Noto Sans CJK SC"/>
-                <a:solidFill>
-                  <a:srgbClr val="1C202C"/>
-                </a:solidFill>
-                <a:latin typeface="Noto Sans CJK SC"/>
-              </a:rPr>
-              <a:t>Chat / Guidance Agent</a:t>
+              <a:t>Chat / Guidance</a:t>
+            </a:r>
+          </a:p>
+          <a:p>
+            <a:pPr>
+              <a:defRPr sz="1400">
+                <a:solidFill>
+                  <a:srgbClr val="1F2333"/>
+                </a:solidFill>
+                <a:latin typeface="Aptos"/>
+              </a:defRPr>
+            </a:pPr>
+          </a:p>
+          <a:p>
+            <a:pPr>
+              <a:defRPr sz="1400">
+                <a:solidFill>
+                  <a:srgbClr val="1F2333"/>
+                </a:solidFill>
+                <a:latin typeface="Aptos"/>
+              </a:defRPr>
+            </a:pPr>
+            <a:r>
+              <a:t>价值：不是空白聊天，</a:t>
+            </a:r>
+          </a:p>
+          <a:p>
+            <a:pPr>
+              <a:defRPr sz="1400">
+                <a:solidFill>
+                  <a:srgbClr val="1F2333"/>
+                </a:solidFill>
+                <a:latin typeface="Aptos"/>
+              </a:defRPr>
+            </a:pPr>
+            <a:r>
+              <a:t>而是围绕具体任务交付</a:t>
             </a:r>
           </a:p>
         </p:txBody>
@@ -25624,45 +25676,8 @@
           </a:bodyPr>
           <a:lstStyle/>
           <a:p>
-            <a:pPr algn="l"/>
-            <a:r>
-              <a:rPr sz="1300" b="1">
-                <a:ea typeface="Noto Sans CJK SC"/>
-                <a:cs typeface="Noto Sans CJK SC"/>
-                <a:solidFill>
-                  <a:srgbClr val="8E5BC8"/>
-                </a:solidFill>
-                <a:latin typeface="Noto Sans CJK SC"/>
-              </a:rPr>
-              <a:t>Models &amp; Tools</a:t>
-            </a:r>
-          </a:p>
-        </p:txBody>
-      </p:sp>
-      <p:sp>
-        <p:nvSpPr>
-          <p:cNvPr id="23" name="TextBox 22"/>
-          <p:cNvSpPr txBox="1"/>
-          <p:nvPr/>
-        </p:nvSpPr>
-        <p:spPr>
-          <a:xfrm>
-            <a:off x="7552944" y="2697479"/>
-            <a:ext cx="1837944" cy="3429000"/>
-          </a:xfrm>
-          <a:prstGeom prst="rect">
-            <a:avLst/>
-          </a:prstGeom>
-          <a:noFill/>
-        </p:spPr>
-        <p:txBody>
-          <a:bodyPr wrap="square" lIns="0" rIns="0" tIns="0" bIns="0">
-            <a:spAutoFit/>
-          </a:bodyPr>
-          <a:lstStyle/>
-          <a:p>
             <a:pPr>
-              <a:defRPr sz="1400">
+              <a:defRPr sz="1500">
                 <a:solidFill>
                   <a:srgbClr val="1F2333"/>
                 </a:solidFill>
@@ -25670,9 +25685,32 @@
               </a:defRPr>
             </a:pPr>
             <a:r>
-              <a:t>LLM: OpenRouter 可选接入（mock/规则路径保证演示可复现）</a:t>
-            </a:r>
-          </a:p>
+              <a:t>可插拔能力层</a:t>
+            </a:r>
+          </a:p>
+        </p:txBody>
+      </p:sp>
+      <p:sp>
+        <p:nvSpPr>
+          <p:cNvPr id="23" name="TextBox 22"/>
+          <p:cNvSpPr txBox="1"/>
+          <p:nvPr/>
+        </p:nvSpPr>
+        <p:spPr>
+          <a:xfrm>
+            <a:off x="7552944" y="2697479"/>
+            <a:ext cx="1837944" cy="3429000"/>
+          </a:xfrm>
+          <a:prstGeom prst="rect">
+            <a:avLst/>
+          </a:prstGeom>
+          <a:noFill/>
+        </p:spPr>
+        <p:txBody>
+          <a:bodyPr wrap="square" lIns="0" rIns="0" tIns="0" bIns="0">
+            <a:spAutoFit/>
+          </a:bodyPr>
+          <a:lstStyle/>
           <a:p>
             <a:pPr>
               <a:defRPr sz="1400">
@@ -25683,7 +25721,7 @@
               </a:defRPr>
             </a:pPr>
             <a:r>
-              <a:t>MaterialSource adapter</a:t>
+              <a:t>模型、公开源、用户材料</a:t>
             </a:r>
           </a:p>
           <a:p>
@@ -25696,7 +25734,7 @@
               </a:defRPr>
             </a:pPr>
             <a:r>
-              <a:t>· 公开 URL · 用户 PDF metadata · repo</a:t>
+              <a:t>都通过 adapter 接入</a:t>
             </a:r>
           </a:p>
           <a:p>
@@ -25708,9 +25746,6 @@
                 <a:latin typeface="Aptos"/>
               </a:defRPr>
             </a:pPr>
-            <a:r>
-              <a:t>· 外部调用失败时向 UI 返回明确状态</a:t>
-            </a:r>
           </a:p>
           <a:p>
             <a:pPr>
@@ -25722,7 +25757,46 @@
               </a:defRPr>
             </a:pPr>
             <a:r>
-              <a:t>上下文以结构化 prompt 注入，不依赖黑盒 RAG</a:t>
+              <a:t>可替换：</a:t>
+            </a:r>
+          </a:p>
+          <a:p>
+            <a:pPr>
+              <a:defRPr sz="1400">
+                <a:solidFill>
+                  <a:srgbClr val="1F2333"/>
+                </a:solidFill>
+                <a:latin typeface="Aptos"/>
+              </a:defRPr>
+            </a:pPr>
+            <a:r>
+              <a:t>· 换模型，不改任务闭环</a:t>
+            </a:r>
+          </a:p>
+          <a:p>
+            <a:pPr>
+              <a:defRPr sz="1400">
+                <a:solidFill>
+                  <a:srgbClr val="1F2333"/>
+                </a:solidFill>
+                <a:latin typeface="Aptos"/>
+              </a:defRPr>
+            </a:pPr>
+            <a:r>
+              <a:t>· 换材料源，不改确认流程</a:t>
+            </a:r>
+          </a:p>
+          <a:p>
+            <a:pPr>
+              <a:defRPr sz="1400">
+                <a:solidFill>
+                  <a:srgbClr val="1F2333"/>
+                </a:solidFill>
+                <a:latin typeface="Aptos"/>
+              </a:defRPr>
+            </a:pPr>
+            <a:r>
+              <a:t>· 调用失败，向 UI 返回状态</a:t>
             </a:r>
           </a:p>
         </p:txBody>
@@ -25840,45 +25914,8 @@
           </a:bodyPr>
           <a:lstStyle/>
           <a:p>
-            <a:pPr algn="l"/>
-            <a:r>
-              <a:rPr sz="1300" b="1">
-                <a:ea typeface="Noto Sans CJK SC"/>
-                <a:cs typeface="Noto Sans CJK SC"/>
-                <a:solidFill>
-                  <a:srgbClr val="1E886F"/>
-                </a:solidFill>
-                <a:latin typeface="Noto Sans CJK SC"/>
-              </a:rPr>
-              <a:t>Data &amp; Memory</a:t>
-            </a:r>
-          </a:p>
-        </p:txBody>
-      </p:sp>
-      <p:sp>
-        <p:nvSpPr>
-          <p:cNvPr id="27" name="TextBox 26"/>
-          <p:cNvSpPr txBox="1"/>
-          <p:nvPr/>
-        </p:nvSpPr>
-        <p:spPr>
-          <a:xfrm>
-            <a:off x="9930384" y="2697479"/>
-            <a:ext cx="1837944" cy="3429000"/>
-          </a:xfrm>
-          <a:prstGeom prst="rect">
-            <a:avLst/>
-          </a:prstGeom>
-          <a:noFill/>
-        </p:spPr>
-        <p:txBody>
-          <a:bodyPr wrap="square" lIns="0" rIns="0" tIns="0" bIns="0">
-            <a:spAutoFit/>
-          </a:bodyPr>
-          <a:lstStyle/>
-          <a:p>
             <a:pPr>
-              <a:defRPr sz="1400">
+              <a:defRPr sz="1500">
                 <a:solidFill>
                   <a:srgbClr val="1F2333"/>
                 </a:solidFill>
@@ -25886,9 +25923,32 @@
               </a:defRPr>
             </a:pPr>
             <a:r>
-              <a:t>SQLite 本地存储</a:t>
-            </a:r>
-          </a:p>
+              <a:t>长期上下文</a:t>
+            </a:r>
+          </a:p>
+        </p:txBody>
+      </p:sp>
+      <p:sp>
+        <p:nvSpPr>
+          <p:cNvPr id="27" name="TextBox 26"/>
+          <p:cNvSpPr txBox="1"/>
+          <p:nvPr/>
+        </p:nvSpPr>
+        <p:spPr>
+          <a:xfrm>
+            <a:off x="9930384" y="2697479"/>
+            <a:ext cx="1837944" cy="3429000"/>
+          </a:xfrm>
+          <a:prstGeom prst="rect">
+            <a:avLst/>
+          </a:prstGeom>
+          <a:noFill/>
+        </p:spPr>
+        <p:txBody>
+          <a:bodyPr wrap="square" lIns="0" rIns="0" tIns="0" bIns="0">
+            <a:spAutoFit/>
+          </a:bodyPr>
+          <a:lstStyle/>
           <a:p>
             <a:pPr>
               <a:defRPr sz="1400">
@@ -25925,7 +25985,7 @@
               </a:defRPr>
             </a:pPr>
             <a:r>
-              <a:t>session/context_refs 绑定讨论上下文</a:t>
+              <a:t>session/context_refs 绑定讨论</a:t>
             </a:r>
           </a:p>
           <a:p>
@@ -25937,8 +25997,31 @@
                 <a:latin typeface="Aptos"/>
               </a:defRPr>
             </a:pPr>
-            <a:r>
-              <a:t>仅公开源 + 用户自主提供 · UI 标注来源</a:t>
+          </a:p>
+          <a:p>
+            <a:pPr>
+              <a:defRPr sz="1400">
+                <a:solidFill>
+                  <a:srgbClr val="1F2333"/>
+                </a:solidFill>
+                <a:latin typeface="Aptos"/>
+              </a:defRPr>
+            </a:pPr>
+            <a:r>
+              <a:t>价值：已确认的结果进入</a:t>
+            </a:r>
+          </a:p>
+          <a:p>
+            <a:pPr>
+              <a:defRPr sz="1400">
+                <a:solidFill>
+                  <a:srgbClr val="1F2333"/>
+                </a:solidFill>
+                <a:latin typeface="Aptos"/>
+              </a:defRPr>
+            </a:pPr>
+            <a:r>
+              <a:t>下一轮任务判断，而非一次性对话</a:t>
             </a:r>
           </a:p>
         </p:txBody>
@@ -25965,17 +26048,16 @@
           </a:bodyPr>
           <a:lstStyle/>
           <a:p>
-            <a:pPr algn="ctr"/>
-            <a:r>
-              <a:rPr sz="1000" b="0">
-                <a:ea typeface="Noto Sans CJK SC"/>
-                <a:cs typeface="Noto Sans CJK SC"/>
-                <a:solidFill>
-                  <a:srgbClr val="5E6574"/>
-                </a:solidFill>
-                <a:latin typeface="Noto Sans CJK SC"/>
-              </a:rPr>
-              <a:t>关键设计:Deep Dive 不绑定单一论文平台,而是通过 MaterialSource 接入多源材料,并通过 BaseSession 抽象把四类任务模板化。</a:t>
+            <a:pPr>
+              <a:defRPr sz="1400">
+                <a:solidFill>
+                  <a:srgbClr val="1F2333"/>
+                </a:solidFill>
+                <a:latin typeface="Aptos"/>
+              </a:defRPr>
+            </a:pPr>
+            <a:r>
+              <a:t>核心优势：换模型、换材料源、换领域配置，都不需要重写「节奏路由 → 任务状态 → 用户确认 → 反馈回写」这条闭环。</a:t>
             </a:r>
           </a:p>
         </p:txBody>

</xml_diff>